<commit_message>
Update UJS presentation slides 5-12 with proposal-to-revenue workflow and consumer-only complaints.
</commit_message>
<xml_diff>
--- a/docs/ujs-presentation/EWUMS-UJS-Presentation-Hindi.pptx
+++ b/docs/ujs-presentation/EWUMS-UJS-Presentation-Hindi.pptx
@@ -661,7 +661,7 @@
           <a:lstStyle/>
           <a:p>
             <a:r>
-              <a:t>प्रस्ताव से अंतिम बिल तक, प्रत्येक चरण भूमिका-आधारित अनुमोदन के साथ दर्ज (JE → AE → EE → वित्त)।</a:t>
+              <a:t>12-चरण DPR अनुमोदन पाइपलाइन — प्रभाग प्रस्ताव से निविदा प्रकाशन तक।</a:t>
             </a:r>
           </a:p>
         </p:txBody>
@@ -731,7 +731,7 @@
           <a:lstStyle/>
           <a:p>
             <a:r>
-              <a:t>लाइव डेमो — 2 मिनट। demo-seed.sql लागू करके अभ्यास करें।</a:t>
+              <a:t>केवल Super Admin योजना बनाता है। प्रभाग टैग होने पर सभी करणप्रयाग कर्मचारी एक ही योजना देखते हैं।</a:t>
             </a:r>
           </a:p>
         </p:txBody>
@@ -801,7 +801,7 @@
           <a:lstStyle/>
           <a:p>
             <a:r>
-              <a:t>लाइव डेमो — 4 मिनट।</a:t>
+              <a:t>विभाग बैठक से पहले पूर्ण प्रस्ताव-से-राजस्व + शिकायत प्रवाह का अभ्यास करें।</a:t>
             </a:r>
           </a:p>
         </p:txBody>
@@ -827,76 +827,6 @@
 </file>
 
 <file path=ppt/notesSlides/notesSlide6.xml><?xml version="1.0" encoding="utf-8"?>
-<p:notes xmlns:a="http://schemas.openxmlformats.org/drawingml/2006/main" xmlns:p="http://schemas.openxmlformats.org/presentationml/2006/main" xmlns:r="http://schemas.openxmlformats.org/officeDocument/2006/relationships">
-  <p:cSld>
-    <p:spTree>
-      <p:nvGrpSpPr>
-        <p:cNvPr id="1" name=""/>
-        <p:cNvGrpSpPr/>
-        <p:nvPr/>
-      </p:nvGrpSpPr>
-      <p:grpSpPr>
-        <a:xfrm>
-          <a:off x="0" y="0"/>
-          <a:ext cx="0" cy="0"/>
-          <a:chOff x="0" y="0"/>
-          <a:chExt cx="0" cy="0"/>
-        </a:xfrm>
-      </p:grpSpPr>
-      <p:sp>
-        <p:nvSpPr>
-          <p:cNvPr id="2" name="Slide Image Placeholder 1"/>
-          <p:cNvSpPr>
-            <a:spLocks noGrp="1"/>
-          </p:cNvSpPr>
-          <p:nvPr>
-            <p:ph type="sldImg" idx="2"/>
-          </p:nvPr>
-        </p:nvSpPr>
-        <p:spPr/>
-      </p:sp>
-      <p:sp>
-        <p:nvSpPr>
-          <p:cNvPr id="3" name="Notes Placeholder 2"/>
-          <p:cNvSpPr>
-            <a:spLocks noGrp="1"/>
-          </p:cNvSpPr>
-          <p:nvPr>
-            <p:ph type="body" idx="3" sz="quarter"/>
-          </p:nvPr>
-        </p:nvSpPr>
-        <p:spPr/>
-        <p:txBody>
-          <a:bodyPr/>
-          <a:lstStyle/>
-          <a:p>
-            <a:r>
-              <a:t>लाइव डेमो — 4 मिनट।</a:t>
-            </a:r>
-          </a:p>
-        </p:txBody>
-      </p:sp>
-      <p:sp>
-        <p:nvSpPr>
-          <p:cNvPr id="4" name="Slide Number Placeholder 3"/>
-          <p:cNvSpPr>
-            <a:spLocks noGrp="1"/>
-          </p:cNvSpPr>
-          <p:nvPr>
-            <p:ph type="sldNum" idx="5" sz="quarter"/>
-          </p:nvPr>
-        </p:nvSpPr>
-        <p:spPr/>
-      </p:sp>
-    </p:spTree>
-  </p:cSld>
-  <p:clrMapOvr>
-    <a:masterClrMapping/>
-  </p:clrMapOvr>
-</p:notes>
-</file>
-
-<file path=ppt/notesSlides/notesSlide7.xml><?xml version="1.0" encoding="utf-8"?>
 <p:notes xmlns:a="http://schemas.openxmlformats.org/drawingml/2006/main" xmlns:p="http://schemas.openxmlformats.org/presentationml/2006/main" xmlns:r="http://schemas.openxmlformats.org/officeDocument/2006/relationships">
   <p:cSld>
     <p:spTree>
@@ -4466,7 +4396,7 @@
                 </a:solidFill>
                 <a:latin typeface="Nirmala UI"/>
               </a:rPr>
-              <a:t>डेमो 3 — राजस्व और नागरिक सेवा</a:t>
+              <a:t>चरण 10: नागरिक शिकायत (केवल जल मित्र)</a:t>
             </a:r>
           </a:p>
           <a:p>
@@ -4477,21 +4407,245 @@
                 </a:solidFill>
                 <a:latin typeface="Nirmala UI"/>
               </a:rPr>
-              <a:t>बिलिंग एवं शिकायत</a:t>
-            </a:r>
-          </a:p>
-        </p:txBody>
-      </p:sp>
-      <p:sp>
-        <p:nvSpPr>
-          <p:cNvPr id="7" name="TextBox 6"/>
+              <a:t>शिकायत — नागरिक दर्ज करे, विभाग निपटाए</a:t>
+            </a:r>
+          </a:p>
+        </p:txBody>
+      </p:sp>
+      <p:graphicFrame>
+        <p:nvGraphicFramePr>
+          <p:cNvPr id="7" name="Table 6"/>
+          <p:cNvGraphicFramePr>
+            <a:graphicFrameLocks noGrp="1"/>
+          </p:cNvGraphicFramePr>
+          <p:nvPr/>
+        </p:nvGraphicFramePr>
+        <p:xfrm>
+          <a:off x="548640" y="1600200"/>
+          <a:ext cx="11094414" cy="1828800"/>
+        </p:xfrm>
+        <a:graphic>
+          <a:graphicData uri="http://schemas.openxmlformats.org/drawingml/2006/table">
+            <a:tbl>
+              <a:tblPr firstRow="1" bandRow="1">
+                <a:tableStyleId>{5C22544A-7EE6-4342-B048-85BDC9FD1C3A}</a:tableStyleId>
+              </a:tblPr>
+              <a:tblGrid>
+                <a:gridCol w="5547207"/>
+                <a:gridCol w="5547207"/>
+              </a:tblGrid>
+              <a:tr h="365760">
+                <a:tc>
+                  <a:txBody>
+                    <a:bodyPr/>
+                    <a:lstStyle/>
+                    <a:p>
+                      <a:r>
+                        <a:rPr sz="1200" b="1">
+                          <a:solidFill>
+                            <a:srgbClr val="FFFFFF"/>
+                          </a:solidFill>
+                          <a:latin typeface="Nirmala UI"/>
+                        </a:rPr>
+                        <a:t>कौन</a:t>
+                      </a:r>
+                    </a:p>
+                  </a:txBody>
+                  <a:tcPr>
+                    <a:solidFill>
+                      <a:srgbClr val="0F172A"/>
+                    </a:solidFill>
+                  </a:tcPr>
+                </a:tc>
+                <a:tc>
+                  <a:txBody>
+                    <a:bodyPr/>
+                    <a:lstStyle/>
+                    <a:p>
+                      <a:r>
+                        <a:rPr sz="1200" b="1">
+                          <a:solidFill>
+                            <a:srgbClr val="FFFFFF"/>
+                          </a:solidFill>
+                          <a:latin typeface="Nirmala UI"/>
+                        </a:rPr>
+                        <a:t>कार्य</a:t>
+                      </a:r>
+                    </a:p>
+                  </a:txBody>
+                  <a:tcPr>
+                    <a:solidFill>
+                      <a:srgbClr val="0F172A"/>
+                    </a:solidFill>
+                  </a:tcPr>
+                </a:tc>
+              </a:tr>
+              <a:tr h="365760">
+                <a:tc>
+                  <a:txBody>
+                    <a:bodyPr/>
+                    <a:lstStyle/>
+                    <a:p>
+                      <a:r>
+                        <a:rPr sz="1100" b="0">
+                          <a:solidFill>
+                            <a:srgbClr val="1E293B"/>
+                          </a:solidFill>
+                          <a:latin typeface="Nirmala UI"/>
+                        </a:rPr>
+                        <a:t>उपभोक्ता</a:t>
+                      </a:r>
+                    </a:p>
+                  </a:txBody>
+                  <a:tcPr/>
+                </a:tc>
+                <a:tc>
+                  <a:txBody>
+                    <a:bodyPr/>
+                    <a:lstStyle/>
+                    <a:p>
+                      <a:r>
+                        <a:rPr sz="1100" b="0">
+                          <a:solidFill>
+                            <a:srgbClr val="1E293B"/>
+                          </a:solidFill>
+                          <a:latin typeface="Nirmala UI"/>
+                        </a:rPr>
+                        <a:t>जल मित्र से शिकायत दर्ज करता है (/portal)</a:t>
+                      </a:r>
+                    </a:p>
+                  </a:txBody>
+                  <a:tcPr/>
+                </a:tc>
+              </a:tr>
+              <a:tr h="365760">
+                <a:tc>
+                  <a:txBody>
+                    <a:bodyPr/>
+                    <a:lstStyle/>
+                    <a:p>
+                      <a:r>
+                        <a:rPr sz="1100" b="0">
+                          <a:solidFill>
+                            <a:srgbClr val="1E293B"/>
+                          </a:solidFill>
+                          <a:latin typeface="Nirmala UI"/>
+                        </a:rPr>
+                        <a:t>EE</a:t>
+                      </a:r>
+                    </a:p>
+                  </a:txBody>
+                  <a:tcPr/>
+                </a:tc>
+                <a:tc>
+                  <a:txBody>
+                    <a:bodyPr/>
+                    <a:lstStyle/>
+                    <a:p>
+                      <a:r>
+                        <a:rPr sz="1100" b="0">
+                          <a:solidFill>
+                            <a:srgbClr val="1E293B"/>
+                          </a:solidFill>
+                          <a:latin typeface="Nirmala UI"/>
+                        </a:rPr>
+                        <a:t>टिकट देखता है → JE को सौंपता है</a:t>
+                      </a:r>
+                    </a:p>
+                  </a:txBody>
+                  <a:tcPr/>
+                </a:tc>
+              </a:tr>
+              <a:tr h="365760">
+                <a:tc>
+                  <a:txBody>
+                    <a:bodyPr/>
+                    <a:lstStyle/>
+                    <a:p>
+                      <a:r>
+                        <a:rPr sz="1100" b="0">
+                          <a:solidFill>
+                            <a:srgbClr val="1E293B"/>
+                          </a:solidFill>
+                          <a:latin typeface="Nirmala UI"/>
+                        </a:rPr>
+                        <a:t>JE</a:t>
+                      </a:r>
+                    </a:p>
+                  </a:txBody>
+                  <a:tcPr/>
+                </a:tc>
+                <a:tc>
+                  <a:txBody>
+                    <a:bodyPr/>
+                    <a:lstStyle/>
+                    <a:p>
+                      <a:r>
+                        <a:rPr sz="1100" b="0">
+                          <a:solidFill>
+                            <a:srgbClr val="1E293B"/>
+                          </a:solidFill>
+                          <a:latin typeface="Nirmala UI"/>
+                        </a:rPr>
+                        <a:t>क्षेत्र में समाधान करता है</a:t>
+                      </a:r>
+                    </a:p>
+                  </a:txBody>
+                  <a:tcPr/>
+                </a:tc>
+              </a:tr>
+              <a:tr h="365760">
+                <a:tc>
+                  <a:txBody>
+                    <a:bodyPr/>
+                    <a:lstStyle/>
+                    <a:p>
+                      <a:r>
+                        <a:rPr sz="1100" b="0">
+                          <a:solidFill>
+                            <a:srgbClr val="1E293B"/>
+                          </a:solidFill>
+                          <a:latin typeface="Nirmala UI"/>
+                        </a:rPr>
+                        <a:t>सिस्टम</a:t>
+                      </a:r>
+                    </a:p>
+                  </a:txBody>
+                  <a:tcPr/>
+                </a:tc>
+                <a:tc>
+                  <a:txBody>
+                    <a:bodyPr/>
+                    <a:lstStyle/>
+                    <a:p>
+                      <a:r>
+                        <a:rPr sz="1100" b="0">
+                          <a:solidFill>
+                            <a:srgbClr val="1E293B"/>
+                          </a:solidFill>
+                          <a:latin typeface="Nirmala UI"/>
+                        </a:rPr>
+                        <a:t>सौंपने पर ईमेल सूचना</a:t>
+                      </a:r>
+                    </a:p>
+                  </a:txBody>
+                  <a:tcPr/>
+                </a:tc>
+              </a:tr>
+            </a:tbl>
+          </a:graphicData>
+        </a:graphic>
+      </p:graphicFrame>
+      <p:sp>
+        <p:nvSpPr>
+          <p:cNvPr id="8" name="TextBox 7"/>
           <p:cNvSpPr txBox="1"/>
           <p:nvPr/>
         </p:nvSpPr>
         <p:spPr>
           <a:xfrm>
-            <a:off x="685800" y="1600200"/>
-            <a:ext cx="10820095" cy="4617720"/>
+            <a:off x="548640" y="5989320"/>
+            <a:ext cx="11094415" cy="411480"/>
           </a:xfrm>
           <a:prstGeom prst="rect">
             <a:avLst/>
@@ -4499,168 +4653,19 @@
           <a:noFill/>
         </p:spPr>
         <p:txBody>
-          <a:bodyPr wrap="square">
+          <a:bodyPr wrap="none">
             <a:spAutoFit/>
           </a:bodyPr>
           <a:lstStyle/>
           <a:p>
-            <a:pPr>
-              <a:spcAft>
-                <a:spcPts val="800"/>
-              </a:spcAft>
-            </a:pPr>
-            <a:r>
-              <a:rPr sz="1400" b="0">
-                <a:solidFill>
-                  <a:srgbClr val="1E293B"/>
-                </a:solidFill>
-                <a:latin typeface="Nirmala UI"/>
-              </a:rPr>
-              <a:t>•  लॉगिन: accounts.hrr@egip.local / Accounts@123 (हरिद्वार ग्रामीण)</a:t>
-            </a:r>
-          </a:p>
-          <a:p>
-            <a:pPr>
-              <a:spcAft>
-                <a:spcPts val="800"/>
-              </a:spcAft>
-            </a:pPr>
-            <a:r>
-              <a:rPr sz="1400" b="0">
-                <a:solidFill>
-                  <a:srgbClr val="1E293B"/>
-                </a:solidFill>
-                <a:latin typeface="Nirmala UI"/>
-              </a:rPr>
-              <a:t>•  नेविगेट: Billing → Revenue KPIs</a:t>
-            </a:r>
-          </a:p>
-          <a:p>
-            <a:pPr>
-              <a:spcAft>
-                <a:spcPts val="800"/>
-              </a:spcAft>
-            </a:pPr>
-            <a:r>
-              <a:rPr sz="1400" b="0">
-                <a:solidFill>
-                  <a:srgbClr val="1E293B"/>
-                </a:solidFill>
-                <a:latin typeface="Nirmala UI"/>
-              </a:rPr>
-              <a:t>•  </a:t>
-            </a:r>
-          </a:p>
-          <a:p>
-            <a:pPr>
-              <a:spcAft>
-                <a:spcPts val="800"/>
-              </a:spcAft>
-            </a:pPr>
-            <a:r>
-              <a:rPr sz="1400" b="0">
-                <a:solidFill>
-                  <a:srgbClr val="1E293B"/>
-                </a:solidFill>
-                <a:latin typeface="Nirmala UI"/>
-              </a:rPr>
-              <a:t>•  दिखाएँ:</a:t>
-            </a:r>
-          </a:p>
-          <a:p>
-            <a:pPr>
-              <a:spcAft>
-                <a:spcPts val="800"/>
-              </a:spcAft>
-            </a:pPr>
-            <a:r>
-              <a:rPr sz="1400" b="0">
-                <a:solidFill>
-                  <a:srgbClr val="1E293B"/>
-                </a:solidFill>
-                <a:latin typeface="Nirmala UI"/>
-              </a:rPr>
-              <a:t>•    • उपभोक्ता कनेक्शन और संग्रह दक्षता</a:t>
-            </a:r>
-          </a:p>
-          <a:p>
-            <a:pPr>
-              <a:spcAft>
-                <a:spcPts val="800"/>
-              </a:spcAft>
-            </a:pPr>
-            <a:r>
-              <a:rPr sz="1400" b="0">
-                <a:solidFill>
-                  <a:srgbClr val="1E293B"/>
-                </a:solidFill>
-                <a:latin typeface="Nirmala UI"/>
-              </a:rPr>
-              <a:t>•    • बहादराबाद उपभोक्ता के लिए नमूना बिल</a:t>
-            </a:r>
-          </a:p>
-          <a:p>
-            <a:pPr>
-              <a:spcAft>
-                <a:spcPts val="800"/>
-              </a:spcAft>
-            </a:pPr>
-            <a:r>
-              <a:rPr sz="1400" b="0">
-                <a:solidFill>
-                  <a:srgbClr val="1E293B"/>
-                </a:solidFill>
-                <a:latin typeface="Nirmala UI"/>
-              </a:rPr>
-              <a:t>•    • शिकायत रजिस्टर (यदि सीड किया गया)</a:t>
-            </a:r>
-          </a:p>
-          <a:p>
-            <a:pPr>
-              <a:spcAft>
-                <a:spcPts val="800"/>
-              </a:spcAft>
-            </a:pPr>
-            <a:r>
-              <a:rPr sz="1400" b="0">
-                <a:solidFill>
-                  <a:srgbClr val="1E293B"/>
-                </a:solidFill>
-                <a:latin typeface="Nirmala UI"/>
-              </a:rPr>
-              <a:t>•    • वैकल्पिक: जल मित्र उपभोक्ता पोर्टल — FHTC-HRR-DEMO-001</a:t>
-            </a:r>
-          </a:p>
-          <a:p>
-            <a:pPr>
-              <a:spcAft>
-                <a:spcPts val="800"/>
-              </a:spcAft>
-            </a:pPr>
-            <a:r>
-              <a:rPr sz="1400" b="0">
-                <a:solidFill>
-                  <a:srgbClr val="1E293B"/>
-                </a:solidFill>
-                <a:latin typeface="Nirmala UI"/>
-              </a:rPr>
-              <a:t>•  </a:t>
-            </a:r>
-          </a:p>
-          <a:p>
-            <a:pPr>
-              <a:spcAft>
-                <a:spcPts val="800"/>
-              </a:spcAft>
-            </a:pPr>
-            <a:r>
-              <a:rPr sz="1400" b="0">
-                <a:solidFill>
-                  <a:srgbClr val="1E293B"/>
-                </a:solidFill>
-                <a:latin typeface="Nirmala UI"/>
-              </a:rPr>
-              <a:t>•  स्क्रिप्ट: "कमीशनिंग के बाद, वही मंच टैरिफ, मीटर रीडिंग और उपभोक्ता स्व-सेवा का प्रबंधन करता है।"</a:t>
+            <a:r>
+              <a:rPr sz="1100" b="0">
+                <a:solidFill>
+                  <a:srgbClr val="64748B"/>
+                </a:solidFill>
+                <a:latin typeface="Nirmala UI"/>
+              </a:rPr>
+              <a:t>महत्वपूर्ण: कर्मचारी शिकायत दर्ज नहीं करते — केवल उपभोक्ता। प्रवाह: टिकट जनरेट → असाइन → समाधान → प्रतिक्रिया → बंद</a:t>
             </a:r>
           </a:p>
         </p:txBody>
@@ -4846,7 +4851,7 @@
                 </a:solidFill>
                 <a:latin typeface="Nirmala UI"/>
               </a:rPr>
-              <a:t>क्षेत्र संचालन — मोबाइल तैयार</a:t>
+              <a:t>चरण 11–12: कमांड सेंटर व ऑडिट</a:t>
             </a:r>
           </a:p>
           <a:p>
@@ -4857,7 +4862,7 @@
                 </a:solidFill>
                 <a:latin typeface="Nirmala UI"/>
               </a:rPr>
-              <a:t>मोबाइल — क्षेत्र बिलिंग और GPS कैप्चर</a:t>
+              <a:t>कमांड सेंटर + ऑडिट ट्रेल</a:t>
             </a:r>
           </a:p>
         </p:txBody>
@@ -4896,7 +4901,7 @@
                 </a:solidFill>
                 <a:latin typeface="Nirmala UI"/>
               </a:rPr>
-              <a:t>•  मोबाइल बिलिंग मार्ग (/mobile-billing) — मीटर रीडिंग, ऑफ़लाइन कतार</a:t>
+              <a:t>•  KPI: संपत्ति, प्रगति, राजस्व, शिकायतें, SLA</a:t>
             </a:r>
           </a:p>
           <a:p>
@@ -4912,7 +4917,7 @@
                 </a:solidFill>
                 <a:latin typeface="Nirmala UI"/>
               </a:rPr>
-              <a:t>•  रीडिंग पर GPS और फ़ोटो साक्ष्य</a:t>
+              <a:t>•  प्रभाग या राज्यव्यापी दृश्य (/dashboard)</a:t>
             </a:r>
           </a:p>
           <a:p>
@@ -4928,7 +4933,7 @@
                 </a:solidFill>
                 <a:latin typeface="Nirmala UI"/>
               </a:rPr>
-              <a:t>•  उपभोक्ता पोर्टल — OTP लॉगिन, हिंदी/अंग्रेज़ी/गढ़वाली/कुमाऊँ (जल मित्र)</a:t>
+              <a:t>•  हर उपयोगकर्ता क्रिया दर्ज — वर्कफ़्लो, मानचित्र, अनुमोदन</a:t>
             </a:r>
           </a:p>
           <a:p>
@@ -4944,7 +4949,41 @@
                 </a:solidFill>
                 <a:latin typeface="Nirmala UI"/>
               </a:rPr>
-              <a:t>•  QR संपत्ति पहचान (आंशिक — स्कैन API लाइव, समर्पित ऐप रोडमैप)</a:t>
+              <a:t>•  ऑडिट ट्रेल — उपयोगकर्ता, प्रभाग, पिछले 24 घंटे फ़िल्टर</a:t>
+            </a:r>
+          </a:p>
+        </p:txBody>
+      </p:sp>
+      <p:sp>
+        <p:nvSpPr>
+          <p:cNvPr id="8" name="TextBox 7"/>
+          <p:cNvSpPr txBox="1"/>
+          <p:nvPr/>
+        </p:nvSpPr>
+        <p:spPr>
+          <a:xfrm>
+            <a:off x="548640" y="5989320"/>
+            <a:ext cx="11094415" cy="411480"/>
+          </a:xfrm>
+          <a:prstGeom prst="rect">
+            <a:avLst/>
+          </a:prstGeom>
+          <a:noFill/>
+        </p:spPr>
+        <p:txBody>
+          <a:bodyPr wrap="none">
+            <a:spAutoFit/>
+          </a:bodyPr>
+          <a:lstStyle/>
+          <a:p>
+            <a:r>
+              <a:rPr sz="1100" b="0">
+                <a:solidFill>
+                  <a:srgbClr val="64748B"/>
+                </a:solidFill>
+                <a:latin typeface="Nirmala UI"/>
+              </a:rPr>
+              <a:t>स्क्रीन: /dashboard · /admin/audit</a:t>
             </a:r>
           </a:p>
         </p:txBody>
@@ -5130,7 +5169,7 @@
                 </a:solidFill>
                 <a:latin typeface="Nirmala UI"/>
               </a:rPr>
-              <a:t>विश्वास और अनुपालन</a:t>
+              <a:t>लाइव डेमो — करणप्रयाग प्रवाह (15 मिनट)</a:t>
             </a:r>
           </a:p>
           <a:p>
@@ -5141,114 +5180,386 @@
                 </a:solidFill>
                 <a:latin typeface="Nirmala UI"/>
               </a:rPr>
-              <a:t>सुरक्षा, ऑडिट ट्रेल और मंडल पहुँच नियंत्रण</a:t>
-            </a:r>
-          </a:p>
-        </p:txBody>
-      </p:sp>
-      <p:sp>
-        <p:nvSpPr>
-          <p:cNvPr id="7" name="TextBox 6"/>
-          <p:cNvSpPr txBox="1"/>
-          <p:nvPr/>
-        </p:nvSpPr>
-        <p:spPr>
-          <a:xfrm>
-            <a:off x="685800" y="1691640"/>
-            <a:ext cx="10820095" cy="4526280"/>
-          </a:xfrm>
-          <a:prstGeom prst="rect">
-            <a:avLst/>
-          </a:prstGeom>
-          <a:noFill/>
-        </p:spPr>
-        <p:txBody>
-          <a:bodyPr wrap="square">
-            <a:spAutoFit/>
-          </a:bodyPr>
-          <a:lstStyle/>
-          <a:p>
-            <a:pPr>
-              <a:spcAft>
-                <a:spcPts val="800"/>
-              </a:spcAft>
-            </a:pPr>
-            <a:r>
-              <a:rPr sz="1600" b="0">
-                <a:solidFill>
-                  <a:srgbClr val="1E293B"/>
-                </a:solidFill>
-                <a:latin typeface="Nirmala UI"/>
-              </a:rPr>
-              <a:t>•  भूमिका-आधारित पहुँच — 25+ UJS भूमिकाएँ (MD, SE, EE, JE, बिलिंग अधिकारी, आदि)</a:t>
-            </a:r>
-          </a:p>
-          <a:p>
-            <a:pPr>
-              <a:spcAft>
-                <a:spcPts val="800"/>
-              </a:spcAft>
-            </a:pPr>
-            <a:r>
-              <a:rPr sz="1600" b="0">
-                <a:solidFill>
-                  <a:srgbClr val="1E293B"/>
-                </a:solidFill>
-                <a:latin typeface="Nirmala UI"/>
-              </a:rPr>
-              <a:t>•  मंडल अलगाव — हरिद्वार JE देहरादून उत्तर डेटा नहीं देख सकता</a:t>
-            </a:r>
-          </a:p>
-          <a:p>
-            <a:pPr>
-              <a:spcAft>
-                <a:spcPts val="800"/>
-              </a:spcAft>
-            </a:pPr>
-            <a:r>
-              <a:rPr sz="1600" b="0">
-                <a:solidFill>
-                  <a:srgbClr val="1E293B"/>
-                </a:solidFill>
-                <a:latin typeface="Nirmala UI"/>
-              </a:rPr>
-              <a:t>•  पूर्ण ऑडिट लॉग — उपयोगकर्ता क्रियाएँ, वर्कफ़्लो इवेंट, मानचित्र पहुँच</a:t>
-            </a:r>
-          </a:p>
-          <a:p>
-            <a:pPr>
-              <a:spcAft>
-                <a:spcPts val="800"/>
-              </a:spcAft>
-            </a:pPr>
-            <a:r>
-              <a:rPr sz="1600" b="0">
-                <a:solidFill>
-                  <a:srgbClr val="1E293B"/>
-                </a:solidFill>
-                <a:latin typeface="Nirmala UI"/>
-              </a:rPr>
-              <a:t>•  वर्कफ़्लो इंजन — कॉन्फ़िगर करने योग्य JE → AE → EE → वित्त श्रृंखलाएँ</a:t>
-            </a:r>
-          </a:p>
-          <a:p>
-            <a:pPr>
-              <a:spcAft>
-                <a:spcPts val="800"/>
-              </a:spcAft>
-            </a:pPr>
-            <a:r>
-              <a:rPr sz="1600" b="0">
-                <a:solidFill>
-                  <a:srgbClr val="1E293B"/>
-                </a:solidFill>
-                <a:latin typeface="Nirmala UI"/>
-              </a:rPr>
-              <a:t>•  सत्र प्रमाणीकरण — JWT, प्रत्येक API पर अनुमति गार्ड</a:t>
-            </a:r>
-          </a:p>
-        </p:txBody>
-      </p:sp>
+              <a:t>लाइव डेमो — करणप्रयाग प्रवाह</a:t>
+            </a:r>
+          </a:p>
+        </p:txBody>
+      </p:sp>
+      <p:graphicFrame>
+        <p:nvGraphicFramePr>
+          <p:cNvPr id="7" name="Table 6"/>
+          <p:cNvGraphicFramePr>
+            <a:graphicFrameLocks noGrp="1"/>
+          </p:cNvGraphicFramePr>
+          <p:nvPr/>
+        </p:nvGraphicFramePr>
+        <p:xfrm>
+          <a:off x="548640" y="1600200"/>
+          <a:ext cx="11094414" cy="2194560"/>
+        </p:xfrm>
+        <a:graphic>
+          <a:graphicData uri="http://schemas.openxmlformats.org/drawingml/2006/table">
+            <a:tbl>
+              <a:tblPr firstRow="1" bandRow="1">
+                <a:tableStyleId>{5C22544A-7EE6-4342-B048-85BDC9FD1C3A}</a:tableStyleId>
+              </a:tblPr>
+              <a:tblGrid>
+                <a:gridCol w="3698138"/>
+                <a:gridCol w="3698138"/>
+                <a:gridCol w="3698138"/>
+              </a:tblGrid>
+              <a:tr h="365760">
+                <a:tc>
+                  <a:txBody>
+                    <a:bodyPr/>
+                    <a:lstStyle/>
+                    <a:p>
+                      <a:r>
+                        <a:rPr sz="1200" b="1">
+                          <a:solidFill>
+                            <a:srgbClr val="FFFFFF"/>
+                          </a:solidFill>
+                          <a:latin typeface="Nirmala UI"/>
+                        </a:rPr>
+                        <a:t>चरण</a:t>
+                      </a:r>
+                    </a:p>
+                  </a:txBody>
+                  <a:tcPr>
+                    <a:solidFill>
+                      <a:srgbClr val="0F172A"/>
+                    </a:solidFill>
+                  </a:tcPr>
+                </a:tc>
+                <a:tc>
+                  <a:txBody>
+                    <a:bodyPr/>
+                    <a:lstStyle/>
+                    <a:p>
+                      <a:r>
+                        <a:rPr sz="1200" b="1">
+                          <a:solidFill>
+                            <a:srgbClr val="FFFFFF"/>
+                          </a:solidFill>
+                          <a:latin typeface="Nirmala UI"/>
+                        </a:rPr>
+                        <a:t>कौन</a:t>
+                      </a:r>
+                    </a:p>
+                  </a:txBody>
+                  <a:tcPr>
+                    <a:solidFill>
+                      <a:srgbClr val="0F172A"/>
+                    </a:solidFill>
+                  </a:tcPr>
+                </a:tc>
+                <a:tc>
+                  <a:txBody>
+                    <a:bodyPr/>
+                    <a:lstStyle/>
+                    <a:p>
+                      <a:r>
+                        <a:rPr sz="1200" b="1">
+                          <a:solidFill>
+                            <a:srgbClr val="FFFFFF"/>
+                          </a:solidFill>
+                          <a:latin typeface="Nirmala UI"/>
+                        </a:rPr>
+                        <a:t>कार्य</a:t>
+                      </a:r>
+                    </a:p>
+                  </a:txBody>
+                  <a:tcPr>
+                    <a:solidFill>
+                      <a:srgbClr val="0F172A"/>
+                    </a:solidFill>
+                  </a:tcPr>
+                </a:tc>
+              </a:tr>
+              <a:tr h="365760">
+                <a:tc>
+                  <a:txBody>
+                    <a:bodyPr/>
+                    <a:lstStyle/>
+                    <a:p>
+                      <a:r>
+                        <a:rPr sz="1100" b="0">
+                          <a:solidFill>
+                            <a:srgbClr val="1E293B"/>
+                          </a:solidFill>
+                          <a:latin typeface="Nirmala UI"/>
+                        </a:rPr>
+                        <a:t>1</a:t>
+                      </a:r>
+                    </a:p>
+                  </a:txBody>
+                  <a:tcPr/>
+                </a:tc>
+                <a:tc>
+                  <a:txBody>
+                    <a:bodyPr/>
+                    <a:lstStyle/>
+                    <a:p>
+                      <a:r>
+                        <a:rPr sz="1100" b="0">
+                          <a:solidFill>
+                            <a:srgbClr val="1E293B"/>
+                          </a:solidFill>
+                          <a:latin typeface="Nirmala UI"/>
+                        </a:rPr>
+                        <a:t>Admin</a:t>
+                      </a:r>
+                    </a:p>
+                  </a:txBody>
+                  <a:tcPr/>
+                </a:tc>
+                <a:tc>
+                  <a:txBody>
+                    <a:bodyPr/>
+                    <a:lstStyle/>
+                    <a:p>
+                      <a:r>
+                        <a:rPr sz="1100" b="0">
+                          <a:solidFill>
+                            <a:srgbClr val="1E293B"/>
+                          </a:solidFill>
+                          <a:latin typeface="Nirmala UI"/>
+                        </a:rPr>
+                        <a:t>योजना बनाए (करणप्रयाग प्रभाग)</a:t>
+                      </a:r>
+                    </a:p>
+                  </a:txBody>
+                  <a:tcPr/>
+                </a:tc>
+              </a:tr>
+              <a:tr h="365760">
+                <a:tc>
+                  <a:txBody>
+                    <a:bodyPr/>
+                    <a:lstStyle/>
+                    <a:p>
+                      <a:r>
+                        <a:rPr sz="1100" b="0">
+                          <a:solidFill>
+                            <a:srgbClr val="1E293B"/>
+                          </a:solidFill>
+                          <a:latin typeface="Nirmala UI"/>
+                        </a:rPr>
+                        <a:t>2</a:t>
+                      </a:r>
+                    </a:p>
+                  </a:txBody>
+                  <a:tcPr/>
+                </a:tc>
+                <a:tc>
+                  <a:txBody>
+                    <a:bodyPr/>
+                    <a:lstStyle/>
+                    <a:p>
+                      <a:r>
+                        <a:rPr sz="1100" b="0">
+                          <a:solidFill>
+                            <a:srgbClr val="1E293B"/>
+                          </a:solidFill>
+                          <a:latin typeface="Nirmala UI"/>
+                        </a:rPr>
+                        <a:t>Admin</a:t>
+                      </a:r>
+                    </a:p>
+                  </a:txBody>
+                  <a:tcPr/>
+                </a:tc>
+                <a:tc>
+                  <a:txBody>
+                    <a:bodyPr/>
+                    <a:lstStyle/>
+                    <a:p>
+                      <a:r>
+                        <a:rPr sz="1100" b="0">
+                          <a:solidFill>
+                            <a:srgbClr val="1E293B"/>
+                          </a:solidFill>
+                          <a:latin typeface="Nirmala UI"/>
+                        </a:rPr>
+                        <a:t>उपभोक्ता पंजीकृत करे (FHTC + मोबाइल)</a:t>
+                      </a:r>
+                    </a:p>
+                  </a:txBody>
+                  <a:tcPr/>
+                </a:tc>
+              </a:tr>
+              <a:tr h="365760">
+                <a:tc>
+                  <a:txBody>
+                    <a:bodyPr/>
+                    <a:lstStyle/>
+                    <a:p>
+                      <a:r>
+                        <a:rPr sz="1100" b="0">
+                          <a:solidFill>
+                            <a:srgbClr val="1E293B"/>
+                          </a:solidFill>
+                          <a:latin typeface="Nirmala UI"/>
+                        </a:rPr>
+                        <a:t>3</a:t>
+                      </a:r>
+                    </a:p>
+                  </a:txBody>
+                  <a:tcPr/>
+                </a:tc>
+                <a:tc>
+                  <a:txBody>
+                    <a:bodyPr/>
+                    <a:lstStyle/>
+                    <a:p>
+                      <a:r>
+                        <a:rPr sz="1100" b="0">
+                          <a:solidFill>
+                            <a:srgbClr val="1E293B"/>
+                          </a:solidFill>
+                          <a:latin typeface="Nirmala UI"/>
+                        </a:rPr>
+                        <a:t>उपभोक्ता</a:t>
+                      </a:r>
+                    </a:p>
+                  </a:txBody>
+                  <a:tcPr/>
+                </a:tc>
+                <a:tc>
+                  <a:txBody>
+                    <a:bodyPr/>
+                    <a:lstStyle/>
+                    <a:p>
+                      <a:r>
+                        <a:rPr sz="1100" b="0">
+                          <a:solidFill>
+                            <a:srgbClr val="1E293B"/>
+                          </a:solidFill>
+                          <a:latin typeface="Nirmala UI"/>
+                        </a:rPr>
+                        <a:t>जल मित्र — शिकायत दर्ज करे</a:t>
+                      </a:r>
+                    </a:p>
+                  </a:txBody>
+                  <a:tcPr/>
+                </a:tc>
+              </a:tr>
+              <a:tr h="365760">
+                <a:tc>
+                  <a:txBody>
+                    <a:bodyPr/>
+                    <a:lstStyle/>
+                    <a:p>
+                      <a:r>
+                        <a:rPr sz="1100" b="0">
+                          <a:solidFill>
+                            <a:srgbClr val="1E293B"/>
+                          </a:solidFill>
+                          <a:latin typeface="Nirmala UI"/>
+                        </a:rPr>
+                        <a:t>4</a:t>
+                      </a:r>
+                    </a:p>
+                  </a:txBody>
+                  <a:tcPr/>
+                </a:tc>
+                <a:tc>
+                  <a:txBody>
+                    <a:bodyPr/>
+                    <a:lstStyle/>
+                    <a:p>
+                      <a:r>
+                        <a:rPr sz="1100" b="0">
+                          <a:solidFill>
+                            <a:srgbClr val="1E293B"/>
+                          </a:solidFill>
+                          <a:latin typeface="Nirmala UI"/>
+                        </a:rPr>
+                        <a:t>EE</a:t>
+                      </a:r>
+                    </a:p>
+                  </a:txBody>
+                  <a:tcPr/>
+                </a:tc>
+                <a:tc>
+                  <a:txBody>
+                    <a:bodyPr/>
+                    <a:lstStyle/>
+                    <a:p>
+                      <a:r>
+                        <a:rPr sz="1100" b="0">
+                          <a:solidFill>
+                            <a:srgbClr val="1E293B"/>
+                          </a:solidFill>
+                          <a:latin typeface="Nirmala UI"/>
+                        </a:rPr>
+                        <a:t>शिकायत इनबॉक्स — JE को सौंपे</a:t>
+                      </a:r>
+                    </a:p>
+                  </a:txBody>
+                  <a:tcPr/>
+                </a:tc>
+              </a:tr>
+              <a:tr h="365760">
+                <a:tc>
+                  <a:txBody>
+                    <a:bodyPr/>
+                    <a:lstStyle/>
+                    <a:p>
+                      <a:r>
+                        <a:rPr sz="1100" b="0">
+                          <a:solidFill>
+                            <a:srgbClr val="1E293B"/>
+                          </a:solidFill>
+                          <a:latin typeface="Nirmala UI"/>
+                        </a:rPr>
+                        <a:t>5</a:t>
+                      </a:r>
+                    </a:p>
+                  </a:txBody>
+                  <a:tcPr/>
+                </a:tc>
+                <a:tc>
+                  <a:txBody>
+                    <a:bodyPr/>
+                    <a:lstStyle/>
+                    <a:p>
+                      <a:r>
+                        <a:rPr sz="1100" b="0">
+                          <a:solidFill>
+                            <a:srgbClr val="1E293B"/>
+                          </a:solidFill>
+                          <a:latin typeface="Nirmala UI"/>
+                        </a:rPr>
+                        <a:t>सभी</a:t>
+                      </a:r>
+                    </a:p>
+                  </a:txBody>
+                  <a:tcPr/>
+                </a:tc>
+                <a:tc>
+                  <a:txBody>
+                    <a:bodyPr/>
+                    <a:lstStyle/>
+                    <a:p>
+                      <a:r>
+                        <a:rPr sz="1100" b="0">
+                          <a:solidFill>
+                            <a:srgbClr val="1E293B"/>
+                          </a:solidFill>
+                          <a:latin typeface="Nirmala UI"/>
+                        </a:rPr>
+                        <a:t>सूचना लॉग + ईमेल अलर्ट</a:t>
+                      </a:r>
+                    </a:p>
+                  </a:txBody>
+                  <a:tcPr/>
+                </a:tc>
+              </a:tr>
+            </a:tbl>
+          </a:graphicData>
+        </a:graphic>
+      </p:graphicFrame>
       <p:sp>
         <p:nvSpPr>
           <p:cNvPr id="8" name="TextBox 7"/>
@@ -5278,7 +5589,7 @@
                 </a:solidFill>
                 <a:latin typeface="Nirmala UI"/>
               </a:rPr>
-              <a:t>डेमो: Audit Trail — पिछले 24 घंटे फ़िल्टर करें</a:t>
+              <a:t>लॉगिन: admin@egip.local / Admin@123 · ee.kpg@egip.local / EE@123</a:t>
             </a:r>
           </a:p>
         </p:txBody>
@@ -9316,7 +9627,7 @@
                 </a:solidFill>
                 <a:latin typeface="Nirmala UI"/>
               </a:rPr>
-              <a:t>योजना एवं निर्माण — लाइव मॉड्यूल</a:t>
+              <a:t>चरण 1–2: DPR व अनुमोदन</a:t>
             </a:r>
           </a:p>
           <a:p>
@@ -9327,7 +9638,7 @@
                 </a:solidFill>
                 <a:latin typeface="Nirmala UI"/>
               </a:rPr>
-              <a:t>योजना एवं निर्माण</a:t>
+              <a:t>योजना पाइपलाइन (12 चरण)</a:t>
             </a:r>
           </a:p>
         </p:txBody>
@@ -9366,7 +9677,7 @@
                 </a:solidFill>
                 <a:latin typeface="Nirmala UI"/>
               </a:rPr>
-              <a:t>1.  DPR और योजना प्रबंधन — 12-चरण अनुमोदन</a:t>
+              <a:t>1.  DPR प्रस्ताव प्रारंभ (प्रभाग EE/JE)</a:t>
             </a:r>
           </a:p>
           <a:p>
@@ -9382,7 +9693,7 @@
                 </a:solidFill>
                 <a:latin typeface="Nirmala UI"/>
               </a:rPr>
-              <a:t>2.  निर्माण प्रबंधन — प्रगति डैशबोर्ड</a:t>
+              <a:t>2.  मुख्यालय समीक्षा → TAC → सचिवालय → स्वीकृति</a:t>
             </a:r>
           </a:p>
           <a:p>
@@ -9398,71 +9709,41 @@
                 </a:solidFill>
                 <a:latin typeface="Nirmala UI"/>
               </a:rPr>
-              <a:t>3.  MB प्रबंधन — माप और सत्यापन</a:t>
-            </a:r>
-          </a:p>
-          <a:p>
-            <a:pPr>
-              <a:spcAft>
-                <a:spcPts val="600"/>
-              </a:spcAft>
-            </a:pPr>
-            <a:r>
-              <a:rPr sz="1500" b="0">
-                <a:solidFill>
-                  <a:srgbClr val="1E293B"/>
-                </a:solidFill>
-                <a:latin typeface="Nirmala UI"/>
-              </a:rPr>
-              <a:t>4.  BOQ और मात्रा समाधान</a:t>
-            </a:r>
-          </a:p>
-          <a:p>
-            <a:pPr>
-              <a:spcAft>
-                <a:spcPts val="600"/>
-              </a:spcAft>
-            </a:pPr>
-            <a:r>
-              <a:rPr sz="1500" b="0">
-                <a:solidFill>
-                  <a:srgbClr val="1E293B"/>
-                </a:solidFill>
-                <a:latin typeface="Nirmala UI"/>
-              </a:rPr>
-              <a:t>5.  RA बिल और ठेकेदार भुगतान</a:t>
-            </a:r>
-          </a:p>
-          <a:p>
-            <a:pPr>
-              <a:spcAft>
-                <a:spcPts val="600"/>
-              </a:spcAft>
-            </a:pPr>
-            <a:r>
-              <a:rPr sz="1500" b="0">
-                <a:solidFill>
-                  <a:srgbClr val="1E293B"/>
-                </a:solidFill>
-                <a:latin typeface="Nirmala UI"/>
-              </a:rPr>
-              <a:t>6.  अंतिम बिल और परियोजना समापन</a:t>
-            </a:r>
-          </a:p>
-          <a:p>
-            <a:pPr>
-              <a:spcAft>
-                <a:spcPts val="600"/>
-              </a:spcAft>
-            </a:pPr>
-            <a:r>
-              <a:rPr sz="1500" b="0">
-                <a:solidFill>
-                  <a:srgbClr val="1E293B"/>
-                </a:solidFill>
-                <a:latin typeface="Nirmala UI"/>
-              </a:rPr>
-              <a:t>7.  भूमि अधिग्रहण प्रबंधन — GIS पार्सल ट्रेस</a:t>
+              <a:t>3.  निविदा प्रकाशित → परियोजना के लिए तैयार</a:t>
+            </a:r>
+          </a:p>
+        </p:txBody>
+      </p:sp>
+      <p:sp>
+        <p:nvSpPr>
+          <p:cNvPr id="8" name="TextBox 7"/>
+          <p:cNvSpPr txBox="1"/>
+          <p:nvPr/>
+        </p:nvSpPr>
+        <p:spPr>
+          <a:xfrm>
+            <a:off x="548640" y="5989320"/>
+            <a:ext cx="11094415" cy="411480"/>
+          </a:xfrm>
+          <a:prstGeom prst="rect">
+            <a:avLst/>
+          </a:prstGeom>
+          <a:noFill/>
+        </p:spPr>
+        <p:txBody>
+          <a:bodyPr wrap="none">
+            <a:spAutoFit/>
+          </a:bodyPr>
+          <a:lstStyle/>
+          <a:p>
+            <a:r>
+              <a:rPr sz="1100" b="0">
+                <a:solidFill>
+                  <a:srgbClr val="64748B"/>
+                </a:solidFill>
+                <a:latin typeface="Nirmala UI"/>
+              </a:rPr>
+              <a:t>स्क्रीन: /dpr-planning · /workflows</a:t>
             </a:r>
           </a:p>
         </p:txBody>
@@ -9648,7 +9929,18 @@
                 </a:solidFill>
                 <a:latin typeface="Nirmala UI"/>
               </a:rPr>
-              <a:t>GIS, संचालन और राजस्व — लाइव मॉड्यूल</a:t>
+              <a:t>चरण 3–4: भूमि व परियोजना</a:t>
+            </a:r>
+          </a:p>
+          <a:p>
+            <a:r>
+              <a:rPr sz="1800" b="0">
+                <a:solidFill>
+                  <a:srgbClr val="F97316"/>
+                </a:solidFill>
+                <a:latin typeface="Nirmala UI"/>
+              </a:rPr>
+              <a:t>भूमि अधिग्रहण → परियोजना पंजीकरण</a:t>
             </a:r>
           </a:p>
         </p:txBody>
@@ -9662,7 +9954,7 @@
         <p:spPr>
           <a:xfrm>
             <a:off x="685800" y="1691640"/>
-            <a:ext cx="10820095" cy="3200400"/>
+            <a:ext cx="10820095" cy="4526280"/>
           </a:xfrm>
           <a:prstGeom prst="rect">
             <a:avLst/>
@@ -9677,135 +9969,65 @@
           <a:p>
             <a:pPr>
               <a:spcAft>
-                <a:spcPts val="1000"/>
+                <a:spcPts val="800"/>
               </a:spcAft>
             </a:pPr>
             <a:r>
-              <a:rPr sz="1600" b="1">
-                <a:solidFill>
-                  <a:srgbClr val="0F172A"/>
-                </a:solidFill>
-                <a:latin typeface="Nirmala UI"/>
-              </a:rPr>
-              <a:t>GIS और संपत्ति: </a:t>
-            </a:r>
-            <a:r>
               <a:rPr sz="1600" b="0">
                 <a:solidFill>
                   <a:srgbClr val="1E293B"/>
                 </a:solidFill>
                 <a:latin typeface="Nirmala UI"/>
               </a:rPr>
-              <a:t>वेब मानचित्र एक्सप्लोरर, संपत्ति रजिस्ट्री, फ़ीचर क्लास</a:t>
+              <a:t>•  GIS पर पाइपलाइन ट्रेस + भूखंड मंजूरी (/land-acquisition)</a:t>
             </a:r>
           </a:p>
           <a:p>
             <a:pPr>
               <a:spcAft>
-                <a:spcPts val="1000"/>
+                <a:spcPts val="800"/>
               </a:spcAft>
             </a:pPr>
             <a:r>
-              <a:rPr sz="1600" b="1">
-                <a:solidFill>
-                  <a:srgbClr val="0F172A"/>
-                </a:solidFill>
-                <a:latin typeface="Nirmala UI"/>
-              </a:rPr>
-              <a:t>संचालन: </a:t>
-            </a:r>
-            <a:r>
               <a:rPr sz="1600" b="0">
                 <a:solidFill>
                   <a:srgbClr val="1E293B"/>
                 </a:solidFill>
                 <a:latin typeface="Nirmala UI"/>
               </a:rPr>
-              <a:t>O&amp;M वर्कफ़्लो (14 चरण), SCADA/IoT, जल गुणवत्ता, शिकायतें, उपभोक्ता</a:t>
+              <a:t>•  Super Admin निविदा-प्रकाशित DPR से परियोजना बनाता है (/projects)</a:t>
             </a:r>
           </a:p>
           <a:p>
             <a:pPr>
               <a:spcAft>
-                <a:spcPts val="1000"/>
+                <a:spcPts val="800"/>
               </a:spcAft>
             </a:pPr>
             <a:r>
-              <a:rPr sz="1600" b="1">
-                <a:solidFill>
-                  <a:srgbClr val="0F172A"/>
-                </a:solidFill>
-                <a:latin typeface="Nirmala UI"/>
-              </a:rPr>
-              <a:t>वाणिज्यिक: </a:t>
-            </a:r>
-            <a:r>
               <a:rPr sz="1600" b="0">
                 <a:solidFill>
                   <a:srgbClr val="1E293B"/>
                 </a:solidFill>
                 <a:latin typeface="Nirmala UI"/>
               </a:rPr>
-              <a:t>बिलिंग और राजस्व, ERP/GL एकीकरण, 15.12 रिपोर्ट</a:t>
+              <a:t>•  प्रभाग कर्मचारी लॉगिन स्वतः बनते हैं (JE, AE, EE, लेखा)</a:t>
             </a:r>
           </a:p>
           <a:p>
             <a:pPr>
               <a:spcAft>
-                <a:spcPts val="1000"/>
+                <a:spcPts val="800"/>
               </a:spcAft>
             </a:pPr>
             <a:r>
-              <a:rPr sz="1600" b="1">
-                <a:solidFill>
-                  <a:srgbClr val="0F172A"/>
-                </a:solidFill>
-                <a:latin typeface="Nirmala UI"/>
-              </a:rPr>
-              <a:t>बुद्धिमत्ता: </a:t>
-            </a:r>
-            <a:r>
               <a:rPr sz="1600" b="0">
                 <a:solidFill>
                   <a:srgbClr val="1E293B"/>
                 </a:solidFill>
                 <a:latin typeface="Nirmala UI"/>
               </a:rPr>
-              <a:t>कार्यकारी डैशबोर्ड, संपत्ति जीवनचक्र, एनालिटिक्स</a:t>
-            </a:r>
-          </a:p>
-        </p:txBody>
-      </p:sp>
-      <p:sp>
-        <p:nvSpPr>
-          <p:cNvPr id="8" name="TextBox 7"/>
-          <p:cNvSpPr txBox="1"/>
-          <p:nvPr/>
-        </p:nvSpPr>
-        <p:spPr>
-          <a:xfrm>
-            <a:off x="548640" y="5989320"/>
-            <a:ext cx="11094415" cy="411480"/>
-          </a:xfrm>
-          <a:prstGeom prst="rect">
-            <a:avLst/>
-          </a:prstGeom>
-          <a:noFill/>
-        </p:spPr>
-        <p:txBody>
-          <a:bodyPr wrap="none">
-            <a:spAutoFit/>
-          </a:bodyPr>
-          <a:lstStyle/>
-          <a:p>
-            <a:r>
-              <a:rPr sz="1100" b="0">
-                <a:solidFill>
-                  <a:srgbClr val="64748B"/>
-                </a:solidFill>
-                <a:latin typeface="Nirmala UI"/>
-              </a:rPr>
-              <a:t>आंशिक (रोडमैप): मोबाइल कार्यबल विस्तार, एंटरप्राइज DMS, QR स्कैन ऐप, ML predictive maintenance</a:t>
+              <a:t>•  माइलस्टोन व बजट स्वीकृत DPR से स्वतः जुड़ते हैं</a:t>
             </a:r>
           </a:p>
         </p:txBody>
@@ -9991,7 +10213,7 @@
                 </a:solidFill>
                 <a:latin typeface="Nirmala UI"/>
               </a:rPr>
-              <a:t>स्थान — सामान्य धागा</a:t>
+              <a:t>चरण 5–6: GIS व निर्माण</a:t>
             </a:r>
           </a:p>
           <a:p>
@@ -10002,7 +10224,7 @@
                 </a:solidFill>
                 <a:latin typeface="Nirmala UI"/>
               </a:rPr>
-              <a:t>GIS — हर संपत्ति और योजना मानचित्र पर</a:t>
+              <a:t>मानचित्र पर निर्माण — हर रुपये का हिसाब</a:t>
             </a:r>
           </a:p>
         </p:txBody>
@@ -10041,7 +10263,7 @@
                 </a:solidFill>
                 <a:latin typeface="Nirmala UI"/>
               </a:rPr>
-              <a:t>•  जिला-लॉक मानचित्र अधिकार क्षेत्र (देहरादून, हरिद्वार)</a:t>
+              <a:t>•  मानचित्र संपत्ति: पाइप, जलाशय, FHTC (/map)</a:t>
             </a:r>
           </a:p>
           <a:p>
@@ -10057,7 +10279,7 @@
                 </a:solidFill>
                 <a:latin typeface="Nirmala UI"/>
               </a:rPr>
-              <a:t>•  पाइपलाइन, जलाशय, FHTC परतें परियोजनाओं से जुड़ी</a:t>
+              <a:t>•  दैनिक DPR → MB → BOQ समाधान → RA बिल</a:t>
             </a:r>
           </a:p>
           <a:p>
@@ -10073,7 +10295,7 @@
                 </a:solidFill>
                 <a:latin typeface="Nirmala UI"/>
               </a:rPr>
-              <a:t>•  भूमि अधिग्रहण: स्वचालित संरेखण ट्रेस + कैडास्ट्रल इंटरसेक्ट</a:t>
+              <a:t>•  JE → AE → EE अनुमोदन श्रृंखला — पूर्ण ऑडिट ट्रेल</a:t>
             </a:r>
           </a:p>
           <a:p>
@@ -10089,23 +10311,7 @@
                 </a:solidFill>
                 <a:latin typeface="Nirmala UI"/>
               </a:rPr>
-              <a:t>•  राजस्व GIS एनालिटिक्स — भूगोल के अनुसार संग्रह</a:t>
-            </a:r>
-          </a:p>
-          <a:p>
-            <a:pPr>
-              <a:spcAft>
-                <a:spcPts val="800"/>
-              </a:spcAft>
-            </a:pPr>
-            <a:r>
-              <a:rPr sz="1600" b="0">
-                <a:solidFill>
-                  <a:srgbClr val="1E293B"/>
-                </a:solidFill>
-                <a:latin typeface="Nirmala UI"/>
-              </a:rPr>
-              <a:t>•  क्षेत्र सत्यापन के लिए उपग्रह बेसमैप (Google / Esri)</a:t>
+              <a:t>•  निर्माण डैशबोर्ड पर भौतिक % व वित्तीय %</a:t>
             </a:r>
           </a:p>
         </p:txBody>
@@ -10139,7 +10345,7 @@
                 </a:solidFill>
                 <a:latin typeface="Nirmala UI"/>
               </a:rPr>
-              <a:t>डेमो: Map Explorer → देहरादून जिला → योजना संपत्तियाँ</a:t>
+              <a:t>स्क्रीन: /projects/{id}/construction</a:t>
             </a:r>
           </a:p>
         </p:txBody>
@@ -10325,7 +10531,7 @@
                 </a:solidFill>
                 <a:latin typeface="Nirmala UI"/>
               </a:rPr>
-              <a:t>डेमो 1 — कमांड सेंटर</a:t>
+              <a:t>चरण 7: O&amp;M हस्तांतरण</a:t>
             </a:r>
           </a:p>
           <a:p>
@@ -10336,7 +10542,7 @@
                 </a:solidFill>
                 <a:latin typeface="Nirmala UI"/>
               </a:rPr>
-              <a:t>कार्यकारी डैशबोर्ड</a:t>
+              <a:t>कमीशनिंग व O&amp;M सौंपना</a:t>
             </a:r>
           </a:p>
         </p:txBody>
@@ -10349,8 +10555,8 @@
         </p:nvSpPr>
         <p:spPr>
           <a:xfrm>
-            <a:off x="685800" y="1600200"/>
-            <a:ext cx="10820095" cy="4617720"/>
+            <a:off x="685800" y="1691640"/>
+            <a:ext cx="10820095" cy="4526280"/>
           </a:xfrm>
           <a:prstGeom prst="rect">
             <a:avLst/>
@@ -10369,13 +10575,13 @@
               </a:spcAft>
             </a:pPr>
             <a:r>
-              <a:rPr sz="1400" b="0">
+              <a:rPr sz="1600" b="0">
                 <a:solidFill>
                   <a:srgbClr val="1E293B"/>
                 </a:solidFill>
                 <a:latin typeface="Nirmala UI"/>
               </a:rPr>
-              <a:t>•  लॉगिन: admin@egip.local / Admin@123</a:t>
+              <a:t>•  पूर्णता चेकलिस्ट — MB, GIS, FHTC, कमीशनिंग प्रमाणपत्र</a:t>
             </a:r>
           </a:p>
           <a:p>
@@ -10385,13 +10591,13 @@
               </a:spcAft>
             </a:pPr>
             <a:r>
-              <a:rPr sz="1400" b="0">
+              <a:rPr sz="1600" b="0">
                 <a:solidFill>
                   <a:srgbClr val="1E293B"/>
                 </a:solidFill>
                 <a:latin typeface="Nirmala UI"/>
               </a:rPr>
-              <a:t>•  नेविगेट: साइडबार → Executive Dashboard (/dashboard)</a:t>
+              <a:t>•  हस्तांतरण प्रमाणपत्र + संपत्ति रजिस्टर</a:t>
             </a:r>
           </a:p>
           <a:p>
@@ -10401,125 +10607,47 @@
               </a:spcAft>
             </a:pPr>
             <a:r>
-              <a:rPr sz="1400" b="0">
+              <a:rPr sz="1600" b="0">
                 <a:solidFill>
                   <a:srgbClr val="1E293B"/>
                 </a:solidFill>
                 <a:latin typeface="Nirmala UI"/>
               </a:rPr>
-              <a:t>•  </a:t>
-            </a:r>
-          </a:p>
-          <a:p>
-            <a:pPr>
-              <a:spcAft>
-                <a:spcPts val="800"/>
-              </a:spcAft>
-            </a:pPr>
-            <a:r>
-              <a:rPr sz="1400" b="0">
-                <a:solidFill>
-                  <a:srgbClr val="1E293B"/>
-                </a:solidFill>
-                <a:latin typeface="Nirmala UI"/>
-              </a:rPr>
-              <a:t>•  दिखाएँ:</a:t>
-            </a:r>
-          </a:p>
-          <a:p>
-            <a:pPr>
-              <a:spcAft>
-                <a:spcPts val="800"/>
-              </a:spcAft>
-            </a:pPr>
-            <a:r>
-              <a:rPr sz="1400" b="0">
-                <a:solidFill>
-                  <a:srgbClr val="1E293B"/>
-                </a:solidFill>
-                <a:latin typeface="Nirmala UI"/>
-              </a:rPr>
-              <a:t>•    • पाँच KPI कार्ड — संपत्ति, अलर्ट, महत्वपूर्ण संपत्ति, परियोजना प्रगति, स्वास्थ्य</a:t>
-            </a:r>
-          </a:p>
-          <a:p>
-            <a:pPr>
-              <a:spcAft>
-                <a:spcPts val="800"/>
-              </a:spcAft>
-            </a:pPr>
-            <a:r>
-              <a:rPr sz="1400" b="0">
-                <a:solidFill>
-                  <a:srgbClr val="1E293B"/>
-                </a:solidFill>
-                <a:latin typeface="Nirmala UI"/>
-              </a:rPr>
-              <a:t>•    • परियोजना प्रगति चार्ट — क्लेमेंट टाउन और बहादराबाद योजनाएँ</a:t>
-            </a:r>
-          </a:p>
-          <a:p>
-            <a:pPr>
-              <a:spcAft>
-                <a:spcPts val="800"/>
-              </a:spcAft>
-            </a:pPr>
-            <a:r>
-              <a:rPr sz="1400" b="0">
-                <a:solidFill>
-                  <a:srgbClr val="1E293B"/>
-                </a:solidFill>
-                <a:latin typeface="Nirmala UI"/>
-              </a:rPr>
-              <a:t>•    • महत्वपूर्ण संपत्ति तालिका</a:t>
-            </a:r>
-          </a:p>
-          <a:p>
-            <a:pPr>
-              <a:spcAft>
-                <a:spcPts val="800"/>
-              </a:spcAft>
-            </a:pPr>
-            <a:r>
-              <a:rPr sz="1400" b="0">
-                <a:solidFill>
-                  <a:srgbClr val="1E293B"/>
-                </a:solidFill>
-                <a:latin typeface="Nirmala UI"/>
-              </a:rPr>
-              <a:t>•    • 20 मंच मॉड्यूल का लिंक</a:t>
-            </a:r>
-          </a:p>
-          <a:p>
-            <a:pPr>
-              <a:spcAft>
-                <a:spcPts val="800"/>
-              </a:spcAft>
-            </a:pPr>
-            <a:r>
-              <a:rPr sz="1400" b="0">
-                <a:solidFill>
-                  <a:srgbClr val="1E293B"/>
-                </a:solidFill>
-                <a:latin typeface="Nirmala UI"/>
-              </a:rPr>
-              <a:t>•  </a:t>
-            </a:r>
-          </a:p>
-          <a:p>
-            <a:pPr>
-              <a:spcAft>
-                <a:spcPts val="800"/>
-              </a:spcAft>
-            </a:pPr>
-            <a:r>
-              <a:rPr sz="1400" b="0">
-                <a:solidFill>
-                  <a:srgbClr val="1E293B"/>
-                </a:solidFill>
-                <a:latin typeface="Nirmala UI"/>
-              </a:rPr>
-              <a:t>•  स्क्रिप्ट: "एक स्क्रीन से, नेतृत्व राज्यव्यापी स्वास्थ्य देखता है। प्रत्येक KPI PostgreSQL से लाइव है — स्थिर रिपोर्ट नहीं।"</a:t>
+              <a:t>•  योजना बिलिंग और उपभोक्ता सेवा के लिए संचालन-तैयार</a:t>
+            </a:r>
+          </a:p>
+        </p:txBody>
+      </p:sp>
+      <p:sp>
+        <p:nvSpPr>
+          <p:cNvPr id="8" name="TextBox 7"/>
+          <p:cNvSpPr txBox="1"/>
+          <p:nvPr/>
+        </p:nvSpPr>
+        <p:spPr>
+          <a:xfrm>
+            <a:off x="548640" y="5989320"/>
+            <a:ext cx="11094415" cy="411480"/>
+          </a:xfrm>
+          <a:prstGeom prst="rect">
+            <a:avLst/>
+          </a:prstGeom>
+          <a:noFill/>
+        </p:spPr>
+        <p:txBody>
+          <a:bodyPr wrap="none">
+            <a:spAutoFit/>
+          </a:bodyPr>
+          <a:lstStyle/>
+          <a:p>
+            <a:r>
+              <a:rPr sz="1100" b="0">
+                <a:solidFill>
+                  <a:srgbClr val="64748B"/>
+                </a:solidFill>
+                <a:latin typeface="Nirmala UI"/>
+              </a:rPr>
+              <a:t>स्क्रीन: /om#handover</a:t>
             </a:r>
           </a:p>
         </p:txBody>
@@ -10705,7 +10833,7 @@
                 </a:solidFill>
                 <a:latin typeface="Nirmala UI"/>
               </a:rPr>
-              <a:t>डेमो 2 — योजना कार्यान्वयन</a:t>
+              <a:t>चरण 8–9: उपभोक्ता व राजस्व</a:t>
             </a:r>
           </a:p>
           <a:p>
@@ -10716,7 +10844,7 @@
                 </a:solidFill>
                 <a:latin typeface="Nirmala UI"/>
               </a:rPr>
-              <a:t>निर्माण प्रवाह</a:t>
+              <a:t>FHTC पंजीकरण → बिलिंग → राजस्व</a:t>
             </a:r>
           </a:p>
         </p:txBody>
@@ -10729,8 +10857,8 @@
         </p:nvSpPr>
         <p:spPr>
           <a:xfrm>
-            <a:off x="685800" y="1600200"/>
-            <a:ext cx="10820095" cy="4617720"/>
+            <a:off x="685800" y="1691640"/>
+            <a:ext cx="10820095" cy="4526280"/>
           </a:xfrm>
           <a:prstGeom prst="rect">
             <a:avLst/>
@@ -10745,177 +10873,99 @@
           <a:p>
             <a:pPr>
               <a:spcAft>
-                <a:spcPts val="800"/>
+                <a:spcPts val="600"/>
               </a:spcAft>
             </a:pPr>
             <a:r>
-              <a:rPr sz="1400" b="0">
+              <a:rPr sz="1500" b="0">
                 <a:solidFill>
                   <a:srgbClr val="1E293B"/>
                 </a:solidFill>
                 <a:latin typeface="Nirmala UI"/>
               </a:rPr>
-              <a:t>•  लॉगिन: je.dnn@egip.local / JE@123 (देहरादून उत्तर JE)</a:t>
+              <a:t>1.  उपभोक्ता पंजीकरण (FHTC + मोबाइल) योजना से जुड़ा</a:t>
             </a:r>
           </a:p>
           <a:p>
             <a:pPr>
               <a:spcAft>
-                <a:spcPts val="800"/>
+                <a:spcPts val="600"/>
               </a:spcAft>
             </a:pPr>
             <a:r>
-              <a:rPr sz="1400" b="0">
+              <a:rPr sz="1500" b="0">
                 <a:solidFill>
                   <a:srgbClr val="1E293B"/>
                 </a:solidFill>
                 <a:latin typeface="Nirmala UI"/>
               </a:rPr>
-              <a:t>•  नेविगेट: Projects → Clement Town Water Supply Scheme</a:t>
+              <a:t>2.  मोबाइल बिलिंग से मीटर रीडिंग (/mobile-billing)</a:t>
             </a:r>
           </a:p>
           <a:p>
             <a:pPr>
               <a:spcAft>
-                <a:spcPts val="800"/>
+                <a:spcPts val="600"/>
               </a:spcAft>
             </a:pPr>
             <a:r>
-              <a:rPr sz="1400" b="0">
+              <a:rPr sz="1500" b="0">
                 <a:solidFill>
                   <a:srgbClr val="1E293B"/>
                 </a:solidFill>
                 <a:latin typeface="Nirmala UI"/>
               </a:rPr>
-              <a:t>•  </a:t>
+              <a:t>3.  बिल जनरेशन → वसूली और बकाया ट्रैकिंग</a:t>
             </a:r>
           </a:p>
           <a:p>
             <a:pPr>
               <a:spcAft>
-                <a:spcPts val="800"/>
+                <a:spcPts val="600"/>
               </a:spcAft>
             </a:pPr>
             <a:r>
-              <a:rPr sz="1400" b="0">
+              <a:rPr sz="1500" b="0">
                 <a:solidFill>
                   <a:srgbClr val="1E293B"/>
                 </a:solidFill>
                 <a:latin typeface="Nirmala UI"/>
               </a:rPr>
-              <a:t>•  दिखाएँ:</a:t>
-            </a:r>
-          </a:p>
-          <a:p>
-            <a:pPr>
-              <a:spcAft>
-                <a:spcPts val="800"/>
-              </a:spcAft>
-            </a:pPr>
-            <a:r>
-              <a:rPr sz="1400" b="0">
-                <a:solidFill>
-                  <a:srgbClr val="1E293B"/>
-                </a:solidFill>
-                <a:latin typeface="Nirmala UI"/>
-              </a:rPr>
-              <a:t>•    • निर्माण डैशबोर्ड — भौतिक 72% / वित्तीय 65%</a:t>
-            </a:r>
-          </a:p>
-          <a:p>
-            <a:pPr>
-              <a:spcAft>
-                <a:spcPts val="800"/>
-              </a:spcAft>
-            </a:pPr>
-            <a:r>
-              <a:rPr sz="1400" b="0">
-                <a:solidFill>
-                  <a:srgbClr val="1E293B"/>
-                </a:solidFill>
-                <a:latin typeface="Nirmala UI"/>
-              </a:rPr>
-              <a:t>•    • MB प्रविष्टि (माप पुस्तक)</a:t>
-            </a:r>
-          </a:p>
-          <a:p>
-            <a:pPr>
-              <a:spcAft>
-                <a:spcPts val="800"/>
-              </a:spcAft>
-            </a:pPr>
-            <a:r>
-              <a:rPr sz="1400" b="0">
-                <a:solidFill>
-                  <a:srgbClr val="1E293B"/>
-                </a:solidFill>
-                <a:latin typeface="Nirmala UI"/>
-              </a:rPr>
-              <a:t>•    • BOQ समाधान</a:t>
-            </a:r>
-          </a:p>
-          <a:p>
-            <a:pPr>
-              <a:spcAft>
-                <a:spcPts val="800"/>
-              </a:spcAft>
-            </a:pPr>
-            <a:r>
-              <a:rPr sz="1400" b="0">
-                <a:solidFill>
-                  <a:srgbClr val="1E293B"/>
-                </a:solidFill>
-                <a:latin typeface="Nirmala UI"/>
-              </a:rPr>
-              <a:t>•    • RA बिल AE अनुमोदन लंबित</a:t>
-            </a:r>
-          </a:p>
-          <a:p>
-            <a:pPr>
-              <a:spcAft>
-                <a:spcPts val="800"/>
-              </a:spcAft>
-            </a:pPr>
-            <a:r>
-              <a:rPr sz="1400" b="0">
-                <a:solidFill>
-                  <a:srgbClr val="1E293B"/>
-                </a:solidFill>
-                <a:latin typeface="Nirmala UI"/>
-              </a:rPr>
-              <a:t>•    • वर्कफ़्लो इनबॉक्स — AE के रूप में अनुमोदित करें (ae.dnn@egip.local)</a:t>
-            </a:r>
-          </a:p>
-          <a:p>
-            <a:pPr>
-              <a:spcAft>
-                <a:spcPts val="800"/>
-              </a:spcAft>
-            </a:pPr>
-            <a:r>
-              <a:rPr sz="1400" b="0">
-                <a:solidFill>
-                  <a:srgbClr val="1E293B"/>
-                </a:solidFill>
-                <a:latin typeface="Nirmala UI"/>
-              </a:rPr>
-              <a:t>•  </a:t>
-            </a:r>
-          </a:p>
-          <a:p>
-            <a:pPr>
-              <a:spcAft>
-                <a:spcPts val="800"/>
-              </a:spcAft>
-            </a:pPr>
-            <a:r>
-              <a:rPr sz="1400" b="0">
-                <a:solidFill>
-                  <a:srgbClr val="1E293B"/>
-                </a:solidFill>
-                <a:latin typeface="Nirmala UI"/>
-              </a:rPr>
-              <a:t>•  स्क्रिप्ट: "मंडल कर्मचारी केवल अपनी योजनाएँ देखते हैं। JE मापता है, AE जाँचता है, EE अनुमोदित करता है — पूर्ण ऑडिट ट्रेल।"</a:t>
+              <a:t>4.  15.12 रिपोर्ट · भूगोल के अनुसार राजस्व GIS एनालिटिक्स</a:t>
+            </a:r>
+          </a:p>
+        </p:txBody>
+      </p:sp>
+      <p:sp>
+        <p:nvSpPr>
+          <p:cNvPr id="8" name="TextBox 7"/>
+          <p:cNvSpPr txBox="1"/>
+          <p:nvPr/>
+        </p:nvSpPr>
+        <p:spPr>
+          <a:xfrm>
+            <a:off x="548640" y="5989320"/>
+            <a:ext cx="11094415" cy="411480"/>
+          </a:xfrm>
+          <a:prstGeom prst="rect">
+            <a:avLst/>
+          </a:prstGeom>
+          <a:noFill/>
+        </p:spPr>
+        <p:txBody>
+          <a:bodyPr wrap="none">
+            <a:spAutoFit/>
+          </a:bodyPr>
+          <a:lstStyle/>
+          <a:p>
+            <a:r>
+              <a:rPr sz="1100" b="0">
+                <a:solidFill>
+                  <a:srgbClr val="64748B"/>
+                </a:solidFill>
+                <a:latin typeface="Nirmala UI"/>
+              </a:rPr>
+              <a:t>स्क्रीन: /billing · /mobile-billing</a:t>
             </a:r>
           </a:p>
         </p:txBody>

</xml_diff>